<commit_message>
Tablet: menú ☰ y plegado; sw v60
</commit_message>
<xml_diff>
--- a/curso/pptx/S07.pptx
+++ b/curso/pptx/S07.pptx
@@ -7149,7 +7149,7 @@
                 </a:solidFill>
                 <a:latin typeface="Nunito Sans"/>
               </a:rPr>
-              <a:t>Conclusión:</a:t>
+              <a:t>结论：</a:t>
             </a:r>
             <a:r>
               <a:rPr sz="2800" b="0">
@@ -7158,7 +7158,7 @@
                 </a:solidFill>
                 <a:latin typeface="Nunito Sans"/>
               </a:rPr>
-              <a:t> lo que quiero que aceptes</a:t>
+              <a:t>我想让你接受的东西</a:t>
             </a:r>
           </a:p>
           <a:p>
@@ -7183,7 +7183,7 @@
                 </a:solidFill>
                 <a:latin typeface="Nunito Sans"/>
               </a:rPr>
-              <a:t>Premisas:</a:t>
+              <a:t>前提：</a:t>
             </a:r>
             <a:r>
               <a:rPr sz="2800" b="0">
@@ -7192,7 +7192,7 @@
                 </a:solidFill>
                 <a:latin typeface="Nunito Sans"/>
               </a:rPr>
-              <a:t> las razones que doy para que lo aceptes</a:t>
+              <a:t>我为了让你接受而给出的理由</a:t>
             </a:r>
           </a:p>
           <a:p>
@@ -7217,7 +7217,7 @@
                 </a:solidFill>
                 <a:latin typeface="Nunito Sans"/>
               </a:rPr>
-              <a:t>Premisa = razón, con un nombre más técnico</a:t>
+              <a:t>前提 = 理由，只是一个更专业的名称</a:t>
             </a:r>
           </a:p>
         </p:txBody>
@@ -7417,7 +7417,7 @@
                 </a:solidFill>
                 <a:latin typeface="Nunito Sans"/>
               </a:rPr>
-              <a:t>Antes de una premisa: «porque», «ya que», «puesto que», «como»</a:t>
+              <a:t>在前提之前：“因为”、“由于”、“既然”、“鉴于”</a:t>
             </a:r>
           </a:p>
           <a:p>
@@ -7442,7 +7442,7 @@
                 </a:solidFill>
                 <a:latin typeface="Nunito Sans"/>
               </a:rPr>
-              <a:t>Antes de una conclusión: «por tanto», «así que», «por eso», «luego»</a:t>
+              <a:t>在结论之前：“因此”、“所以”、“这就是为什么”、“于是”</a:t>
             </a:r>
           </a:p>
           <a:p>
@@ -7467,7 +7467,7 @@
                 </a:solidFill>
                 <a:latin typeface="Nunito Sans"/>
               </a:rPr>
-              <a:t>A veces no hay indicador: hay que pensar qué apoya a qué</a:t>
+              <a:t>有时候没有标志词：要想一想什么在支持什么</a:t>
             </a:r>
           </a:p>
           <a:p>
@@ -7492,7 +7492,7 @@
                 </a:solidFill>
                 <a:latin typeface="Nunito Sans"/>
               </a:rPr>
-              <a:t>Ojo: «porque» a veces explica una causa, no da una razón</a:t>
+              <a:t>注意：“因为”有时解释的是原因，而不是给出理由</a:t>
             </a:r>
           </a:p>
         </p:txBody>
@@ -8129,7 +8129,7 @@
                 </a:solidFill>
                 <a:latin typeface="Nunito Sans"/>
               </a:rPr>
-              <a:t>Una orden sola: «¡Cállate!»</a:t>
+              <a:t>单独的一个命令：“闭嘴！”</a:t>
             </a:r>
           </a:p>
           <a:p>
@@ -8154,7 +8154,7 @@
                 </a:solidFill>
                 <a:latin typeface="Nunito Sans"/>
               </a:rPr>
-              <a:t>Una opinión sin razones: «El fútbol es lo mejor»</a:t>
+              <a:t>没有理由的观点：“足球是最棒的”</a:t>
             </a:r>
           </a:p>
           <a:p>
@@ -8179,7 +8179,7 @@
                 </a:solidFill>
                 <a:latin typeface="Nunito Sans"/>
               </a:rPr>
-              <a:t>Una pregunta: «¿Vienes al cine?»</a:t>
+              <a:t>一个问题：“你来看电影吗？”</a:t>
             </a:r>
           </a:p>
           <a:p>
@@ -8204,7 +8204,7 @@
                 </a:solidFill>
                 <a:latin typeface="Nunito Sans"/>
               </a:rPr>
-              <a:t>Datos sueltos, sin conclusión</a:t>
+              <a:t>零散的数据，没有结论</a:t>
             </a:r>
           </a:p>
         </p:txBody>
@@ -8334,7 +8334,7 @@
                 </a:solidFill>
                 <a:latin typeface="Nunito Sans"/>
               </a:rPr>
-              <a:t>Hay algo que se quiere probar: la conclusión</a:t>
+              <a:t>有一个想要证明的东西：结论</a:t>
             </a:r>
           </a:p>
           <a:p>
@@ -8359,7 +8359,7 @@
                 </a:solidFill>
                 <a:latin typeface="Nunito Sans"/>
               </a:rPr>
-              <a:t>Hay al menos una razón que lo apoya: una premisa</a:t>
+              <a:t>至少有一个支持它的理由：一个前提</a:t>
             </a:r>
           </a:p>
           <a:p>
@@ -8384,7 +8384,7 @@
                 </a:solidFill>
                 <a:latin typeface="Nunito Sans"/>
               </a:rPr>
-              <a:t>«Ven al cine hoy: la peli la quitan mañana»</a:t>
+              <a:t>“今天去看电影吧：这部电影明天就下映了”</a:t>
             </a:r>
           </a:p>
         </p:txBody>

</xml_diff>